<commit_message>
finalized credit note flow + cleanup
- removed 2.4 type completely
- single button for 5.1 issuance
- credit notes shown as 'Εκδόθηκε', subtracted from totals
- auto-refresh history + auto-retry 603
- toast auto-dismiss + visual upgrade
- cents-based payment validation
- added reset-invoices script
</commit_message>
<xml_diff>
--- a/myAade-Presentation.pptx
+++ b/myAade-Presentation.pptx
@@ -144,7 +144,7 @@
     </p:spTree>
     <p:extLst>
       <p:ext uri="{BB962C8B-B14F-4D97-AF65-F5344CB8AC3E}">
-        <p14:creationId xmlns:p14="http://schemas.microsoft.com/office/powerpoint/2010/main" val="3315898965"/>
+        <p14:creationId xmlns:p14="http://schemas.microsoft.com/office/powerpoint/2010/main" val="1685586650"/>
       </p:ext>
     </p:extLst>
   </p:cSld>
@@ -1740,8 +1740,8 @@
         </p:nvSpPr>
         <p:spPr>
           <a:xfrm>
-            <a:off x="396814" y="6492240"/>
-            <a:ext cx="1143863" cy="274320"/>
+            <a:off x="9601200" y="6492240"/>
+            <a:ext cx="2377440" cy="274320"/>
           </a:xfrm>
           <a:prstGeom prst="rect">
             <a:avLst/>
@@ -2550,7 +2550,7 @@
         </p:nvSpPr>
         <p:spPr>
           <a:xfrm>
-            <a:off x="-966158" y="6492240"/>
+            <a:off x="9601200" y="6492240"/>
             <a:ext cx="2377440" cy="274320"/>
           </a:xfrm>
           <a:prstGeom prst="rect">
@@ -3743,7 +3743,7 @@
         </p:nvSpPr>
         <p:spPr>
           <a:xfrm>
-            <a:off x="-905774" y="6492240"/>
+            <a:off x="9601200" y="6492240"/>
             <a:ext cx="2377440" cy="274320"/>
           </a:xfrm>
           <a:prstGeom prst="rect">
@@ -3910,7 +3910,7 @@
                 <a:ea typeface="Calibri" pitchFamily="34" charset="-122"/>
                 <a:cs typeface="Calibri" pitchFamily="34" charset="-120"/>
               </a:rPr>
-              <a:t>B2B · Τύποι 1.1 · 2.1 · 2.4 · 5.1</a:t>
+              <a:t>B2B · Τύποι 1.1 · 2.1 · 2.4</a:t>
             </a:r>
             <a:endParaRPr lang="en-US" sz="1100" dirty="0"/>
           </a:p>
@@ -4002,6 +4002,187 @@
             <a:avLst/>
           </a:prstGeom>
           <a:solidFill>
+            <a:srgbClr val="F43F5E"/>
+          </a:solidFill>
+          <a:ln w="12700">
+            <a:solidFill>
+              <a:srgbClr val="F43F5E"/>
+            </a:solidFill>
+            <a:prstDash val="solid"/>
+          </a:ln>
+        </p:spPr>
+        <p:txBody>
+          <a:bodyPr/>
+          <a:lstStyle/>
+          <a:p>
+            <a:endParaRPr lang="el-GR"/>
+          </a:p>
+        </p:txBody>
+      </p:sp>
+      <p:sp>
+        <p:nvSpPr>
+          <p:cNvPr id="12" name="Text 10"/>
+          <p:cNvSpPr/>
+          <p:nvPr/>
+        </p:nvSpPr>
+        <p:spPr>
+          <a:xfrm>
+            <a:off x="4617720" y="1508760"/>
+            <a:ext cx="3291840" cy="457200"/>
+          </a:xfrm>
+          <a:prstGeom prst="rect">
+            <a:avLst/>
+          </a:prstGeom>
+          <a:noFill/>
+          <a:ln/>
+        </p:spPr>
+        <p:txBody>
+          <a:bodyPr wrap="square" rtlCol="0" anchor="ctr"/>
+          <a:lstStyle/>
+          <a:p>
+            <a:pPr marL="0" indent="0">
+              <a:buNone/>
+            </a:pPr>
+            <a:r>
+              <a:rPr lang="en-US" sz="1600" b="1" dirty="0">
+                <a:solidFill>
+                  <a:srgbClr val="F1F5F9"/>
+                </a:solidFill>
+                <a:latin typeface="Calibri" pitchFamily="34" charset="0"/>
+                <a:ea typeface="Calibri" pitchFamily="34" charset="-122"/>
+                <a:cs typeface="Calibri" pitchFamily="34" charset="-120"/>
+              </a:rPr>
+              <a:t>Πιστωτικά Τιμολόγια</a:t>
+            </a:r>
+            <a:endParaRPr lang="en-US" sz="1600" dirty="0"/>
+          </a:p>
+        </p:txBody>
+      </p:sp>
+      <p:sp>
+        <p:nvSpPr>
+          <p:cNvPr id="13" name="Text 11"/>
+          <p:cNvSpPr/>
+          <p:nvPr/>
+        </p:nvSpPr>
+        <p:spPr>
+          <a:xfrm>
+            <a:off x="4617720" y="2057400"/>
+            <a:ext cx="3291840" cy="411480"/>
+          </a:xfrm>
+          <a:prstGeom prst="rect">
+            <a:avLst/>
+          </a:prstGeom>
+          <a:noFill/>
+          <a:ln/>
+        </p:spPr>
+        <p:txBody>
+          <a:bodyPr wrap="square" rtlCol="0" anchor="ctr"/>
+          <a:lstStyle/>
+          <a:p>
+            <a:pPr marL="0" indent="0">
+              <a:buNone/>
+            </a:pPr>
+            <a:r>
+              <a:rPr lang="en-US" sz="1100" i="1" dirty="0">
+                <a:solidFill>
+                  <a:srgbClr val="F43F5E"/>
+                </a:solidFill>
+                <a:latin typeface="Calibri" pitchFamily="34" charset="0"/>
+                <a:ea typeface="Calibri" pitchFamily="34" charset="-122"/>
+                <a:cs typeface="Calibri" pitchFamily="34" charset="-120"/>
+              </a:rPr>
+              <a:t>Τύπος 5.1 · με correlatedInvoices</a:t>
+            </a:r>
+            <a:endParaRPr lang="en-US" sz="1100" dirty="0"/>
+          </a:p>
+        </p:txBody>
+      </p:sp>
+      <p:sp>
+        <p:nvSpPr>
+          <p:cNvPr id="14" name="Text 12"/>
+          <p:cNvSpPr/>
+          <p:nvPr/>
+        </p:nvSpPr>
+        <p:spPr>
+          <a:xfrm>
+            <a:off x="4617720" y="2560320"/>
+            <a:ext cx="3291840" cy="822960"/>
+          </a:xfrm>
+          <a:prstGeom prst="rect">
+            <a:avLst/>
+          </a:prstGeom>
+          <a:noFill/>
+          <a:ln/>
+        </p:spPr>
+        <p:txBody>
+          <a:bodyPr wrap="square" rtlCol="0" anchor="t"/>
+          <a:lstStyle/>
+          <a:p>
+            <a:pPr marL="0" indent="0">
+              <a:buNone/>
+            </a:pPr>
+            <a:r>
+              <a:rPr lang="en-US" sz="1200" dirty="0">
+                <a:solidFill>
+                  <a:srgbClr val="94A3B8"/>
+                </a:solidFill>
+                <a:latin typeface="Calibri" pitchFamily="34" charset="0"/>
+                <a:ea typeface="Calibri" pitchFamily="34" charset="-122"/>
+                <a:cs typeface="Calibri" pitchFamily="34" charset="-120"/>
+              </a:rPr>
+              <a:t>Searchable picker αρχικού · auto-fill ποσού/πελάτη</a:t>
+            </a:r>
+            <a:endParaRPr lang="en-US" sz="1200" dirty="0"/>
+          </a:p>
+        </p:txBody>
+      </p:sp>
+      <p:sp>
+        <p:nvSpPr>
+          <p:cNvPr id="15" name="Shape 13"/>
+          <p:cNvSpPr/>
+          <p:nvPr/>
+        </p:nvSpPr>
+        <p:spPr>
+          <a:xfrm>
+            <a:off x="8138160" y="1280160"/>
+            <a:ext cx="3657600" cy="2194560"/>
+          </a:xfrm>
+          <a:prstGeom prst="rect">
+            <a:avLst/>
+          </a:prstGeom>
+          <a:solidFill>
+            <a:srgbClr val="1E293B"/>
+          </a:solidFill>
+          <a:ln w="12700">
+            <a:solidFill>
+              <a:srgbClr val="334155"/>
+            </a:solidFill>
+            <a:prstDash val="solid"/>
+          </a:ln>
+        </p:spPr>
+        <p:txBody>
+          <a:bodyPr/>
+          <a:lstStyle/>
+          <a:p>
+            <a:endParaRPr lang="el-GR"/>
+          </a:p>
+        </p:txBody>
+      </p:sp>
+      <p:sp>
+        <p:nvSpPr>
+          <p:cNvPr id="16" name="Shape 14"/>
+          <p:cNvSpPr/>
+          <p:nvPr/>
+        </p:nvSpPr>
+        <p:spPr>
+          <a:xfrm>
+            <a:off x="8138160" y="1280160"/>
+            <a:ext cx="73152" cy="2194560"/>
+          </a:xfrm>
+          <a:prstGeom prst="rect">
+            <a:avLst/>
+          </a:prstGeom>
+          <a:solidFill>
             <a:srgbClr val="10B981"/>
           </a:solidFill>
           <a:ln w="12700">
@@ -4021,13 +4202,13 @@
       </p:sp>
       <p:sp>
         <p:nvSpPr>
-          <p:cNvPr id="12" name="Text 10"/>
-          <p:cNvSpPr/>
-          <p:nvPr/>
-        </p:nvSpPr>
-        <p:spPr>
-          <a:xfrm>
-            <a:off x="4617720" y="1508760"/>
+          <p:cNvPr id="17" name="Text 15"/>
+          <p:cNvSpPr/>
+          <p:nvPr/>
+        </p:nvSpPr>
+        <p:spPr>
+          <a:xfrm>
+            <a:off x="8412480" y="1508760"/>
             <a:ext cx="3291840" cy="457200"/>
           </a:xfrm>
           <a:prstGeom prst="rect">
@@ -4060,13 +4241,13 @@
       </p:sp>
       <p:sp>
         <p:nvSpPr>
-          <p:cNvPr id="13" name="Text 11"/>
-          <p:cNvSpPr/>
-          <p:nvPr/>
-        </p:nvSpPr>
-        <p:spPr>
-          <a:xfrm>
-            <a:off x="4617720" y="2057400"/>
+          <p:cNvPr id="18" name="Text 16"/>
+          <p:cNvSpPr/>
+          <p:nvPr/>
+        </p:nvSpPr>
+        <p:spPr>
+          <a:xfrm>
+            <a:off x="8412480" y="2057400"/>
             <a:ext cx="3291840" cy="411480"/>
           </a:xfrm>
           <a:prstGeom prst="rect">
@@ -4099,13 +4280,13 @@
       </p:sp>
       <p:sp>
         <p:nvSpPr>
-          <p:cNvPr id="14" name="Text 12"/>
-          <p:cNvSpPr/>
-          <p:nvPr/>
-        </p:nvSpPr>
-        <p:spPr>
-          <a:xfrm>
-            <a:off x="4617720" y="2560320"/>
+          <p:cNvPr id="19" name="Text 17"/>
+          <p:cNvSpPr/>
+          <p:nvPr/>
+        </p:nvSpPr>
+        <p:spPr>
+          <a:xfrm>
+            <a:off x="8412480" y="2560320"/>
             <a:ext cx="3291840" cy="822960"/>
           </a:xfrm>
           <a:prstGeom prst="rect">
@@ -4138,13 +4319,13 @@
       </p:sp>
       <p:sp>
         <p:nvSpPr>
-          <p:cNvPr id="15" name="Shape 13"/>
-          <p:cNvSpPr/>
-          <p:nvPr/>
-        </p:nvSpPr>
-        <p:spPr>
-          <a:xfrm>
-            <a:off x="8138160" y="1280160"/>
+          <p:cNvPr id="20" name="Shape 18"/>
+          <p:cNvSpPr/>
+          <p:nvPr/>
+        </p:nvSpPr>
+        <p:spPr>
+          <a:xfrm>
+            <a:off x="548640" y="3657600"/>
             <a:ext cx="3657600" cy="2194560"/>
           </a:xfrm>
           <a:prstGeom prst="rect">
@@ -4170,13 +4351,13 @@
       </p:sp>
       <p:sp>
         <p:nvSpPr>
-          <p:cNvPr id="16" name="Shape 14"/>
-          <p:cNvSpPr/>
-          <p:nvPr/>
-        </p:nvSpPr>
-        <p:spPr>
-          <a:xfrm>
-            <a:off x="8138160" y="1280160"/>
+          <p:cNvPr id="21" name="Shape 19"/>
+          <p:cNvSpPr/>
+          <p:nvPr/>
+        </p:nvSpPr>
+        <p:spPr>
+          <a:xfrm>
+            <a:off x="548640" y="3657600"/>
             <a:ext cx="73152" cy="2194560"/>
           </a:xfrm>
           <a:prstGeom prst="rect">
@@ -4202,13 +4383,13 @@
       </p:sp>
       <p:sp>
         <p:nvSpPr>
-          <p:cNvPr id="17" name="Text 15"/>
-          <p:cNvSpPr/>
-          <p:nvPr/>
-        </p:nvSpPr>
-        <p:spPr>
-          <a:xfrm>
-            <a:off x="8412480" y="1508760"/>
+          <p:cNvPr id="22" name="Text 20"/>
+          <p:cNvSpPr/>
+          <p:nvPr/>
+        </p:nvSpPr>
+        <p:spPr>
+          <a:xfrm>
+            <a:off x="822960" y="3886200"/>
             <a:ext cx="3291840" cy="457200"/>
           </a:xfrm>
           <a:prstGeom prst="rect">
@@ -4241,13 +4422,13 @@
       </p:sp>
       <p:sp>
         <p:nvSpPr>
-          <p:cNvPr id="18" name="Text 16"/>
-          <p:cNvSpPr/>
-          <p:nvPr/>
-        </p:nvSpPr>
-        <p:spPr>
-          <a:xfrm>
-            <a:off x="8412480" y="2057400"/>
+          <p:cNvPr id="23" name="Text 21"/>
+          <p:cNvSpPr/>
+          <p:nvPr/>
+        </p:nvSpPr>
+        <p:spPr>
+          <a:xfrm>
+            <a:off x="822960" y="4434840"/>
             <a:ext cx="3291840" cy="411480"/>
           </a:xfrm>
           <a:prstGeom prst="rect">
@@ -4280,13 +4461,13 @@
       </p:sp>
       <p:sp>
         <p:nvSpPr>
-          <p:cNvPr id="19" name="Text 17"/>
-          <p:cNvSpPr/>
-          <p:nvPr/>
-        </p:nvSpPr>
-        <p:spPr>
-          <a:xfrm>
-            <a:off x="8412480" y="2560320"/>
+          <p:cNvPr id="24" name="Text 22"/>
+          <p:cNvSpPr/>
+          <p:nvPr/>
+        </p:nvSpPr>
+        <p:spPr>
+          <a:xfrm>
+            <a:off x="822960" y="4937760"/>
             <a:ext cx="3291840" cy="822960"/>
           </a:xfrm>
           <a:prstGeom prst="rect">
@@ -4319,13 +4500,13 @@
       </p:sp>
       <p:sp>
         <p:nvSpPr>
-          <p:cNvPr id="20" name="Shape 18"/>
-          <p:cNvSpPr/>
-          <p:nvPr/>
-        </p:nvSpPr>
-        <p:spPr>
-          <a:xfrm>
-            <a:off x="548640" y="3657600"/>
+          <p:cNvPr id="25" name="Shape 23"/>
+          <p:cNvSpPr/>
+          <p:nvPr/>
+        </p:nvSpPr>
+        <p:spPr>
+          <a:xfrm>
+            <a:off x="4343400" y="3657600"/>
             <a:ext cx="3657600" cy="2194560"/>
           </a:xfrm>
           <a:prstGeom prst="rect">
@@ -4351,13 +4532,13 @@
       </p:sp>
       <p:sp>
         <p:nvSpPr>
-          <p:cNvPr id="21" name="Shape 19"/>
-          <p:cNvSpPr/>
-          <p:nvPr/>
-        </p:nvSpPr>
-        <p:spPr>
-          <a:xfrm>
-            <a:off x="548640" y="3657600"/>
+          <p:cNvPr id="26" name="Shape 24"/>
+          <p:cNvSpPr/>
+          <p:nvPr/>
+        </p:nvSpPr>
+        <p:spPr>
+          <a:xfrm>
+            <a:off x="4343400" y="3657600"/>
             <a:ext cx="73152" cy="2194560"/>
           </a:xfrm>
           <a:prstGeom prst="rect">
@@ -4383,13 +4564,13 @@
       </p:sp>
       <p:sp>
         <p:nvSpPr>
-          <p:cNvPr id="22" name="Text 20"/>
-          <p:cNvSpPr/>
-          <p:nvPr/>
-        </p:nvSpPr>
-        <p:spPr>
-          <a:xfrm>
-            <a:off x="822960" y="3886200"/>
+          <p:cNvPr id="27" name="Text 25"/>
+          <p:cNvSpPr/>
+          <p:nvPr/>
+        </p:nvSpPr>
+        <p:spPr>
+          <a:xfrm>
+            <a:off x="4617720" y="3886200"/>
             <a:ext cx="3291840" cy="457200"/>
           </a:xfrm>
           <a:prstGeom prst="rect">
@@ -4422,13 +4603,13 @@
       </p:sp>
       <p:sp>
         <p:nvSpPr>
-          <p:cNvPr id="23" name="Text 21"/>
-          <p:cNvSpPr/>
-          <p:nvPr/>
-        </p:nvSpPr>
-        <p:spPr>
-          <a:xfrm>
-            <a:off x="822960" y="4434840"/>
+          <p:cNvPr id="28" name="Text 26"/>
+          <p:cNvSpPr/>
+          <p:nvPr/>
+        </p:nvSpPr>
+        <p:spPr>
+          <a:xfrm>
+            <a:off x="4617720" y="4434840"/>
             <a:ext cx="3291840" cy="411480"/>
           </a:xfrm>
           <a:prstGeom prst="rect">
@@ -4461,13 +4642,13 @@
       </p:sp>
       <p:sp>
         <p:nvSpPr>
-          <p:cNvPr id="24" name="Text 22"/>
-          <p:cNvSpPr/>
-          <p:nvPr/>
-        </p:nvSpPr>
-        <p:spPr>
-          <a:xfrm>
-            <a:off x="822960" y="4937760"/>
+          <p:cNvPr id="29" name="Text 27"/>
+          <p:cNvSpPr/>
+          <p:nvPr/>
+        </p:nvSpPr>
+        <p:spPr>
+          <a:xfrm>
+            <a:off x="4617720" y="4937760"/>
             <a:ext cx="3291840" cy="822960"/>
           </a:xfrm>
           <a:prstGeom prst="rect">
@@ -4500,13 +4681,13 @@
       </p:sp>
       <p:sp>
         <p:nvSpPr>
-          <p:cNvPr id="25" name="Shape 23"/>
-          <p:cNvSpPr/>
-          <p:nvPr/>
-        </p:nvSpPr>
-        <p:spPr>
-          <a:xfrm>
-            <a:off x="4343400" y="3657600"/>
+          <p:cNvPr id="30" name="Shape 28"/>
+          <p:cNvSpPr/>
+          <p:nvPr/>
+        </p:nvSpPr>
+        <p:spPr>
+          <a:xfrm>
+            <a:off x="8138160" y="3657600"/>
             <a:ext cx="3657600" cy="2194560"/>
           </a:xfrm>
           <a:prstGeom prst="rect">
@@ -4532,187 +4713,6 @@
       </p:sp>
       <p:sp>
         <p:nvSpPr>
-          <p:cNvPr id="26" name="Shape 24"/>
-          <p:cNvSpPr/>
-          <p:nvPr/>
-        </p:nvSpPr>
-        <p:spPr>
-          <a:xfrm>
-            <a:off x="4343400" y="3657600"/>
-            <a:ext cx="73152" cy="2194560"/>
-          </a:xfrm>
-          <a:prstGeom prst="rect">
-            <a:avLst/>
-          </a:prstGeom>
-          <a:solidFill>
-            <a:srgbClr val="F43F5E"/>
-          </a:solidFill>
-          <a:ln w="12700">
-            <a:solidFill>
-              <a:srgbClr val="F43F5E"/>
-            </a:solidFill>
-            <a:prstDash val="solid"/>
-          </a:ln>
-        </p:spPr>
-        <p:txBody>
-          <a:bodyPr/>
-          <a:lstStyle/>
-          <a:p>
-            <a:endParaRPr lang="el-GR"/>
-          </a:p>
-        </p:txBody>
-      </p:sp>
-      <p:sp>
-        <p:nvSpPr>
-          <p:cNvPr id="27" name="Text 25"/>
-          <p:cNvSpPr/>
-          <p:nvPr/>
-        </p:nvSpPr>
-        <p:spPr>
-          <a:xfrm>
-            <a:off x="4617720" y="3886200"/>
-            <a:ext cx="3291840" cy="457200"/>
-          </a:xfrm>
-          <a:prstGeom prst="rect">
-            <a:avLst/>
-          </a:prstGeom>
-          <a:noFill/>
-          <a:ln/>
-        </p:spPr>
-        <p:txBody>
-          <a:bodyPr wrap="square" rtlCol="0" anchor="ctr"/>
-          <a:lstStyle/>
-          <a:p>
-            <a:pPr marL="0" indent="0">
-              <a:buNone/>
-            </a:pPr>
-            <a:r>
-              <a:rPr lang="en-US" sz="1600" b="1" dirty="0">
-                <a:solidFill>
-                  <a:srgbClr val="F1F5F9"/>
-                </a:solidFill>
-                <a:latin typeface="Calibri" pitchFamily="34" charset="0"/>
-                <a:ea typeface="Calibri" pitchFamily="34" charset="-122"/>
-                <a:cs typeface="Calibri" pitchFamily="34" charset="-120"/>
-              </a:rPr>
-              <a:t>Ιστορικό &amp; Αναζήτηση</a:t>
-            </a:r>
-            <a:endParaRPr lang="en-US" sz="1600" dirty="0"/>
-          </a:p>
-        </p:txBody>
-      </p:sp>
-      <p:sp>
-        <p:nvSpPr>
-          <p:cNvPr id="28" name="Text 26"/>
-          <p:cNvSpPr/>
-          <p:nvPr/>
-        </p:nvSpPr>
-        <p:spPr>
-          <a:xfrm>
-            <a:off x="4617720" y="4434840"/>
-            <a:ext cx="3291840" cy="411480"/>
-          </a:xfrm>
-          <a:prstGeom prst="rect">
-            <a:avLst/>
-          </a:prstGeom>
-          <a:noFill/>
-          <a:ln/>
-        </p:spPr>
-        <p:txBody>
-          <a:bodyPr wrap="square" rtlCol="0" anchor="ctr"/>
-          <a:lstStyle/>
-          <a:p>
-            <a:pPr marL="0" indent="0">
-              <a:buNone/>
-            </a:pPr>
-            <a:r>
-              <a:rPr lang="en-US" sz="1100" i="1" dirty="0">
-                <a:solidFill>
-                  <a:srgbClr val="F43F5E"/>
-                </a:solidFill>
-                <a:latin typeface="Calibri" pitchFamily="34" charset="0"/>
-                <a:ea typeface="Calibri" pitchFamily="34" charset="-122"/>
-                <a:cs typeface="Calibri" pitchFamily="34" charset="-120"/>
-              </a:rPr>
-              <a:t>Φίλτρα ΑΦΜ / MARK / Ημερομηνίες</a:t>
-            </a:r>
-            <a:endParaRPr lang="en-US" sz="1100" dirty="0"/>
-          </a:p>
-        </p:txBody>
-      </p:sp>
-      <p:sp>
-        <p:nvSpPr>
-          <p:cNvPr id="29" name="Text 27"/>
-          <p:cNvSpPr/>
-          <p:nvPr/>
-        </p:nvSpPr>
-        <p:spPr>
-          <a:xfrm>
-            <a:off x="4617720" y="4937760"/>
-            <a:ext cx="3291840" cy="822960"/>
-          </a:xfrm>
-          <a:prstGeom prst="rect">
-            <a:avLst/>
-          </a:prstGeom>
-          <a:noFill/>
-          <a:ln/>
-        </p:spPr>
-        <p:txBody>
-          <a:bodyPr wrap="square" rtlCol="0" anchor="t"/>
-          <a:lstStyle/>
-          <a:p>
-            <a:pPr marL="0" indent="0">
-              <a:buNone/>
-            </a:pPr>
-            <a:r>
-              <a:rPr lang="en-US" sz="1200" dirty="0">
-                <a:solidFill>
-                  <a:srgbClr val="94A3B8"/>
-                </a:solidFill>
-                <a:latin typeface="Calibri" pitchFamily="34" charset="0"/>
-                <a:ea typeface="Calibri" pitchFamily="34" charset="-122"/>
-                <a:cs typeface="Calibri" pitchFamily="34" charset="-120"/>
-              </a:rPr>
-              <a:t>Pagination + σύνολα περιόδου από backend</a:t>
-            </a:r>
-            <a:endParaRPr lang="en-US" sz="1200" dirty="0"/>
-          </a:p>
-        </p:txBody>
-      </p:sp>
-      <p:sp>
-        <p:nvSpPr>
-          <p:cNvPr id="30" name="Shape 28"/>
-          <p:cNvSpPr/>
-          <p:nvPr/>
-        </p:nvSpPr>
-        <p:spPr>
-          <a:xfrm>
-            <a:off x="8138160" y="3657600"/>
-            <a:ext cx="3657600" cy="2194560"/>
-          </a:xfrm>
-          <a:prstGeom prst="rect">
-            <a:avLst/>
-          </a:prstGeom>
-          <a:solidFill>
-            <a:srgbClr val="1E293B"/>
-          </a:solidFill>
-          <a:ln w="12700">
-            <a:solidFill>
-              <a:srgbClr val="334155"/>
-            </a:solidFill>
-            <a:prstDash val="solid"/>
-          </a:ln>
-        </p:spPr>
-        <p:txBody>
-          <a:bodyPr/>
-          <a:lstStyle/>
-          <a:p>
-            <a:endParaRPr lang="el-GR"/>
-          </a:p>
-        </p:txBody>
-      </p:sp>
-      <p:sp>
-        <p:nvSpPr>
           <p:cNvPr id="31" name="Shape 29"/>
           <p:cNvSpPr/>
           <p:nvPr/>
@@ -4776,7 +4776,7 @@
                 <a:ea typeface="Calibri" pitchFamily="34" charset="-122"/>
                 <a:cs typeface="Calibri" pitchFamily="34" charset="-120"/>
               </a:rPr>
-              <a:t>Mobile-First UI</a:t>
+              <a:t>Ιστορικό · Mobile UI</a:t>
             </a:r>
             <a:endParaRPr lang="en-US" sz="1600" dirty="0"/>
           </a:p>
@@ -4815,7 +4815,7 @@
                 <a:ea typeface="Calibri" pitchFamily="34" charset="-122"/>
                 <a:cs typeface="Calibri" pitchFamily="34" charset="-120"/>
               </a:rPr>
-              <a:t>Responsive sidebar · Filter modal</a:t>
+              <a:t>Φίλτρα ΑΦΜ / MARK / Ημερομηνίες</a:t>
             </a:r>
             <a:endParaRPr lang="en-US" sz="1100" dirty="0"/>
           </a:p>
@@ -4854,7 +4854,7 @@
                 <a:ea typeface="Calibri" pitchFamily="34" charset="-122"/>
                 <a:cs typeface="Calibri" pitchFamily="34" charset="-120"/>
               </a:rPr>
-              <a:t>Card view σε κινητό · Skeleton loaders</a:t>
+              <a:t>Pagination + σύνολα + responsive cards</a:t>
             </a:r>
             <a:endParaRPr lang="en-US" sz="1200" dirty="0"/>
           </a:p>
@@ -5011,7 +5011,7 @@
         </p:nvSpPr>
         <p:spPr>
           <a:xfrm>
-            <a:off x="-862642" y="6497416"/>
+            <a:off x="9601200" y="6492240"/>
             <a:ext cx="2377440" cy="274320"/>
           </a:xfrm>
           <a:prstGeom prst="rect">
@@ -7213,7 +7213,7 @@
         </p:nvSpPr>
         <p:spPr>
           <a:xfrm>
-            <a:off x="-802257" y="6492240"/>
+            <a:off x="9601200" y="6492240"/>
             <a:ext cx="2377440" cy="274320"/>
           </a:xfrm>
           <a:prstGeom prst="rect">
@@ -7962,7 +7962,7 @@
                 <a:ea typeface="Calibri" pitchFamily="34" charset="-122"/>
                 <a:cs typeface="Calibri" pitchFamily="34" charset="-120"/>
               </a:rPr>
-              <a:t>Auto-retry στο 603 · tidNsp naming · transactionId dedup</a:t>
+              <a:t>Auto-retry 603 · tidNsp naming · correlatedInvoices για 5.1</a:t>
             </a:r>
             <a:endParaRPr lang="en-US" sz="1100" dirty="0"/>
           </a:p>

</xml_diff>